<commit_message>
docs: clarify market value and revenue impact
</commit_message>
<xml_diff>
--- a/Demo/Presentation/StreamDrop_Twitch_해커톤_기획안_v4.pptx
+++ b/Demo/Presentation/StreamDrop_Twitch_해커톤_기획안_v4.pptx
@@ -2,27 +2,27 @@
 <file path=ppt/presentation.xml><?xml version="1.0" encoding="utf-8"?>
 <p:presentation xmlns:p="http://schemas.openxmlformats.org/presentationml/2006/main">
   <p:sldMasterIdLst>
-    <p:sldMasterId xmlns:r="http://schemas.openxmlformats.org/officeDocument/2006/relationships" id="2147483648" r:id="R1dd9160fc6b64966"/>
+    <p:sldMasterId xmlns:r="http://schemas.openxmlformats.org/officeDocument/2006/relationships" id="2147483648" r:id="Re7168b9342134715"/>
   </p:sldMasterIdLst>
   <p:notesMasterIdLst>
-    <p:notesMasterId xmlns:r="http://schemas.openxmlformats.org/officeDocument/2006/relationships" r:id="Ra82a4abed0f14fd7"/>
+    <p:notesMasterId xmlns:r="http://schemas.openxmlformats.org/officeDocument/2006/relationships" r:id="Rd8551c0fedab4848"/>
   </p:notesMasterIdLst>
   <p:sldIdLst>
-    <p:sldId xmlns:r="http://schemas.openxmlformats.org/officeDocument/2006/relationships" id="256" r:id="Rdc5335feb75147b5"/>
-    <p:sldId xmlns:r="http://schemas.openxmlformats.org/officeDocument/2006/relationships" id="257" r:id="Rb46ce49ffa384168"/>
-    <p:sldId xmlns:r="http://schemas.openxmlformats.org/officeDocument/2006/relationships" id="258" r:id="R31bf4d51636247a8"/>
-    <p:sldId xmlns:r="http://schemas.openxmlformats.org/officeDocument/2006/relationships" id="259" r:id="R3178aafc76c14b6a"/>
-    <p:sldId xmlns:r="http://schemas.openxmlformats.org/officeDocument/2006/relationships" id="260" r:id="R65154064b95440ba"/>
-    <p:sldId xmlns:r="http://schemas.openxmlformats.org/officeDocument/2006/relationships" id="261" r:id="R8df6cd4821f941a1"/>
-    <p:sldId xmlns:r="http://schemas.openxmlformats.org/officeDocument/2006/relationships" id="262" r:id="R0e63c386518a4d56"/>
-    <p:sldId xmlns:r="http://schemas.openxmlformats.org/officeDocument/2006/relationships" id="263" r:id="R0849018d470845ba"/>
-    <p:sldId xmlns:r="http://schemas.openxmlformats.org/officeDocument/2006/relationships" id="264" r:id="Rd1416814568241d7"/>
-    <p:sldId xmlns:r="http://schemas.openxmlformats.org/officeDocument/2006/relationships" id="265" r:id="R900bb63551b14c0b"/>
-    <p:sldId xmlns:r="http://schemas.openxmlformats.org/officeDocument/2006/relationships" id="266" r:id="Rd16c9204992d4f5b"/>
-    <p:sldId xmlns:r="http://schemas.openxmlformats.org/officeDocument/2006/relationships" id="267" r:id="R73e935b320754a33"/>
-    <p:sldId xmlns:r="http://schemas.openxmlformats.org/officeDocument/2006/relationships" id="268" r:id="R9faab8ebd486456f"/>
-    <p:sldId xmlns:r="http://schemas.openxmlformats.org/officeDocument/2006/relationships" id="269" r:id="R7c2c7993c1b14dff"/>
-    <p:sldId xmlns:r="http://schemas.openxmlformats.org/officeDocument/2006/relationships" id="270" r:id="R8d8253801dd24ba9"/>
+    <p:sldId xmlns:r="http://schemas.openxmlformats.org/officeDocument/2006/relationships" id="256" r:id="Rcb28a23777ea461f"/>
+    <p:sldId xmlns:r="http://schemas.openxmlformats.org/officeDocument/2006/relationships" id="257" r:id="R9ec2a984143746b2"/>
+    <p:sldId xmlns:r="http://schemas.openxmlformats.org/officeDocument/2006/relationships" id="258" r:id="Rf54a0d74dd9a4c6e"/>
+    <p:sldId xmlns:r="http://schemas.openxmlformats.org/officeDocument/2006/relationships" id="259" r:id="R8a51b1f6f4b44636"/>
+    <p:sldId xmlns:r="http://schemas.openxmlformats.org/officeDocument/2006/relationships" id="260" r:id="Rc4a53dcd8a924c95"/>
+    <p:sldId xmlns:r="http://schemas.openxmlformats.org/officeDocument/2006/relationships" id="261" r:id="R19694f6cb3ca4482"/>
+    <p:sldId xmlns:r="http://schemas.openxmlformats.org/officeDocument/2006/relationships" id="262" r:id="Rd91ff4eb06a94829"/>
+    <p:sldId xmlns:r="http://schemas.openxmlformats.org/officeDocument/2006/relationships" id="263" r:id="R8416deb8ae5a45c3"/>
+    <p:sldId xmlns:r="http://schemas.openxmlformats.org/officeDocument/2006/relationships" id="264" r:id="R7e7be9e47cf847e3"/>
+    <p:sldId xmlns:r="http://schemas.openxmlformats.org/officeDocument/2006/relationships" id="265" r:id="R41afae2b17a6463d"/>
+    <p:sldId xmlns:r="http://schemas.openxmlformats.org/officeDocument/2006/relationships" id="266" r:id="R8c521cff8daf4bd0"/>
+    <p:sldId xmlns:r="http://schemas.openxmlformats.org/officeDocument/2006/relationships" id="267" r:id="R719afedb33c740e2"/>
+    <p:sldId xmlns:r="http://schemas.openxmlformats.org/officeDocument/2006/relationships" id="268" r:id="R1ffd8c91ee5d41cd"/>
+    <p:sldId xmlns:r="http://schemas.openxmlformats.org/officeDocument/2006/relationships" id="269" r:id="Rbe2b2b1d157c477a"/>
+    <p:sldId xmlns:r="http://schemas.openxmlformats.org/officeDocument/2006/relationships" id="270" r:id="R2534a5044e004d2b"/>
   </p:sldIdLst>
   <p:sldSz cx="12192000" cy="6858000"/>
   <p:notesSz cx="6858000" cy="9144000"/>
@@ -966,12 +966,12 @@
           </a:p>
           <a:p xmlns:a="http://schemas.openxmlformats.org/drawingml/2006/main">
             <a:r>
-              <a:t>주최자 캠페인 이용료와 경품·후속 주문 수수료가 수익원입니다.</a:t>
-            </a:r>
-          </a:p>
-          <a:p xmlns:a="http://schemas.openxmlformats.org/drawingml/2006/main">
-            <a:r>
-              <a:t>팔로우 채널·참가 국가·선택 상품을 AI가 분석해 Top 3를 추천하고, 다음 이벤트와 계속 구매를 유도합니다.</a:t>
+              <a:t>글로벌 팬 참여를 국경 없는 구매 여정으로 전환하고, K-CON·게임·팬미팅·스포츠까지 확장할 수 있습니다.</a:t>
+            </a:r>
+          </a:p>
+          <a:p xmlns:a="http://schemas.openxmlformats.org/drawingml/2006/main">
+            <a:r>
+              <a:t>캠페인 운영 이용료와 경품·후속 주문 수수료를 만들고, AI 추천으로 반복 구매와 고객가치를 높입니다.</a:t>
             </a:r>
           </a:p>
           <a:p xmlns:a="http://schemas.openxmlformats.org/drawingml/2006/main">
@@ -1944,7 +1944,7 @@
   </p:cSld>
   <p:clrMap bg1="lt1" tx1="dk1" bg2="lt2" tx2="dk2" accent1="accent1" accent2="accent2" accent3="accent3" accent4="accent4" accent5="accent5" accent6="accent6" hlink="hlink" folHlink="folHlink"/>
   <p:sldLayoutIdLst>
-    <p:sldLayoutId xmlns:r="http://schemas.openxmlformats.org/officeDocument/2006/relationships" id="2147483649" r:id="R80d9fa5cf8124ba8"/>
+    <p:sldLayoutId xmlns:r="http://schemas.openxmlformats.org/officeDocument/2006/relationships" id="2147483649" r:id="Ra96b3f66f75c4c17"/>
   </p:sldLayoutIdLst>
   <p:txStyles>
     <p:titleStyle>
@@ -4558,7 +4558,7 @@
           <p:cNvPr id="29" name="stage-10-title">
             <a:extLst xmlns:a="http://schemas.openxmlformats.org/drawingml/2006/main">
               <a:ext uri="{FF2B5EF4-FFF2-40B4-BE49-F238E27FC236}">
-                <a16:creationId xmlns:a16="http://schemas.microsoft.com/office/drawing/2014/main" id="{1E789049-6332-4ED7-BFC9-A9B54B50455A}"/>
+                <a16:creationId xmlns:a16="http://schemas.microsoft.com/office/drawing/2014/main" id="{E910FFAD-5E20-4DA0-BB1C-B5F94528CE26}"/>
               </a:ext>
             </a:extLst>
           </p:cNvPr>
@@ -4614,7 +4614,7 @@
           <p:cNvPr id="30" name="stage-10-subtitle">
             <a:extLst xmlns:a="http://schemas.openxmlformats.org/drawingml/2006/main">
               <a:ext uri="{FF2B5EF4-FFF2-40B4-BE49-F238E27FC236}">
-                <a16:creationId xmlns:a16="http://schemas.microsoft.com/office/drawing/2014/main" id="{103EAF6F-FD2C-4AA6-969D-9908D5E98740}"/>
+                <a16:creationId xmlns:a16="http://schemas.microsoft.com/office/drawing/2014/main" id="{50CA0B04-941B-4ACF-94B7-8A65C755F5DF}"/>
               </a:ext>
             </a:extLst>
           </p:cNvPr>
@@ -4670,7 +4670,7 @@
           <p:cNvPr id="31" name="stage-10-page">
             <a:extLst xmlns:a="http://schemas.openxmlformats.org/drawingml/2006/main">
               <a:ext uri="{FF2B5EF4-FFF2-40B4-BE49-F238E27FC236}">
-                <a16:creationId xmlns:a16="http://schemas.microsoft.com/office/drawing/2014/main" id="{BE664989-2FEB-4A4C-91B9-623777C3A071}"/>
+                <a16:creationId xmlns:a16="http://schemas.microsoft.com/office/drawing/2014/main" id="{6C1B4CFE-4B4B-4E7D-9A8F-5C4D31BC3C19}"/>
               </a:ext>
             </a:extLst>
           </p:cNvPr>
@@ -4726,7 +4726,7 @@
           <p:cNvPr id="32" name="gift-landing-frame">
             <a:extLst xmlns:a="http://schemas.openxmlformats.org/drawingml/2006/main">
               <a:ext uri="{FF2B5EF4-FFF2-40B4-BE49-F238E27FC236}">
-                <a16:creationId xmlns:a16="http://schemas.microsoft.com/office/drawing/2014/main" id="{482D79B4-4862-4425-8C8E-603AE494DCB3}"/>
+                <a16:creationId xmlns:a16="http://schemas.microsoft.com/office/drawing/2014/main" id="{A8AA1FE2-118E-4BE1-93F7-EFA991639FBA}"/>
               </a:ext>
             </a:extLst>
           </p:cNvPr>
@@ -4765,7 +4765,7 @@
           <p:nvPr/>
         </p:nvPicPr>
         <p:blipFill>
-          <a:blip xmlns:r="http://schemas.openxmlformats.org/officeDocument/2006/relationships" xmlns:a="http://schemas.openxmlformats.org/drawingml/2006/main" r:embed="R6aea0611e0414a71"/>
+          <a:blip xmlns:r="http://schemas.openxmlformats.org/officeDocument/2006/relationships" xmlns:a="http://schemas.openxmlformats.org/drawingml/2006/main" r:embed="Re8ff731431d1447f"/>
           <a:stretch xmlns:a="http://schemas.openxmlformats.org/drawingml/2006/main"/>
         </p:blipFill>
         <p:spPr>
@@ -6288,7 +6288,7 @@
           <p:cNvPr id="29" name="stage-11-title">
             <a:extLst xmlns:a="http://schemas.openxmlformats.org/drawingml/2006/main">
               <a:ext uri="{FF2B5EF4-FFF2-40B4-BE49-F238E27FC236}">
-                <a16:creationId xmlns:a16="http://schemas.microsoft.com/office/drawing/2014/main" id="{BE97B072-CEB6-4BDC-AB08-A5251D7EAEDE}"/>
+                <a16:creationId xmlns:a16="http://schemas.microsoft.com/office/drawing/2014/main" id="{0003D6F7-460F-45E3-B225-A21B909F531D}"/>
               </a:ext>
             </a:extLst>
           </p:cNvPr>
@@ -6344,7 +6344,7 @@
           <p:cNvPr id="30" name="stage-11-subtitle">
             <a:extLst xmlns:a="http://schemas.openxmlformats.org/drawingml/2006/main">
               <a:ext uri="{FF2B5EF4-FFF2-40B4-BE49-F238E27FC236}">
-                <a16:creationId xmlns:a16="http://schemas.microsoft.com/office/drawing/2014/main" id="{12B33DB7-1CEB-4710-BBF6-4F968A236A88}"/>
+                <a16:creationId xmlns:a16="http://schemas.microsoft.com/office/drawing/2014/main" id="{A0105B20-DF40-4BDE-B338-567A94CE76F8}"/>
               </a:ext>
             </a:extLst>
           </p:cNvPr>
@@ -6400,7 +6400,7 @@
           <p:cNvPr id="31" name="stage-11-page">
             <a:extLst xmlns:a="http://schemas.openxmlformats.org/drawingml/2006/main">
               <a:ext uri="{FF2B5EF4-FFF2-40B4-BE49-F238E27FC236}">
-                <a16:creationId xmlns:a16="http://schemas.microsoft.com/office/drawing/2014/main" id="{42E7BD7E-B856-4876-969E-322589D5C11F}"/>
+                <a16:creationId xmlns:a16="http://schemas.microsoft.com/office/drawing/2014/main" id="{91D4252E-47B7-45B7-8F67-1B717643F8A0}"/>
               </a:ext>
             </a:extLst>
           </p:cNvPr>
@@ -6456,7 +6456,7 @@
           <p:cNvPr id="32" name="gift-barcode-frame">
             <a:extLst xmlns:a="http://schemas.openxmlformats.org/drawingml/2006/main">
               <a:ext uri="{FF2B5EF4-FFF2-40B4-BE49-F238E27FC236}">
-                <a16:creationId xmlns:a16="http://schemas.microsoft.com/office/drawing/2014/main" id="{A9EDB928-28D7-4376-B4E3-1EC4DCF221D3}"/>
+                <a16:creationId xmlns:a16="http://schemas.microsoft.com/office/drawing/2014/main" id="{82E23799-2DB1-41EC-874D-3CD2ACD64EFA}"/>
               </a:ext>
             </a:extLst>
           </p:cNvPr>
@@ -6495,7 +6495,7 @@
           <p:nvPr/>
         </p:nvPicPr>
         <p:blipFill>
-          <a:blip xmlns:r="http://schemas.openxmlformats.org/officeDocument/2006/relationships" xmlns:a="http://schemas.openxmlformats.org/drawingml/2006/main" r:embed="Rda7a4c459f7940f5"/>
+          <a:blip xmlns:r="http://schemas.openxmlformats.org/officeDocument/2006/relationships" xmlns:a="http://schemas.openxmlformats.org/drawingml/2006/main" r:embed="R79cb03cb80e0452d"/>
           <a:stretch xmlns:a="http://schemas.openxmlformats.org/drawingml/2006/main"/>
         </p:blipFill>
         <p:spPr>
@@ -9515,7 +9515,7 @@
         <p:spPr>
           <a:xfrm xmlns:a="http://schemas.openxmlformats.org/drawingml/2006/main">
             <a:off x="552450" y="3848100"/>
-            <a:ext cx="1714500" cy="285750"/>
+            <a:ext cx="2095500" cy="285750"/>
           </a:xfrm>
           <a:prstGeom xmlns:a="http://schemas.openxmlformats.org/drawingml/2006/main" prst="rect">
             <a:avLst/>
@@ -9555,7 +9555,7 @@
                 <a:ea typeface="Apple SD Gothic Neo"/>
                 <a:cs typeface="Apple SD Gothic Neo"/>
               </a:rPr>
-              <a:t>현실적인 수익 구조</a:t>
+              <a:t>시장 가치</a:t>
             </a:r>
           </a:p>
         </p:txBody>
@@ -9577,7 +9577,7 @@
         <p:spPr>
           <a:xfrm xmlns:a="http://schemas.openxmlformats.org/drawingml/2006/main">
             <a:off x="552450" y="4248150"/>
-            <a:ext cx="4762500" cy="457200"/>
+            <a:ext cx="5143500" cy="323850"/>
           </a:xfrm>
           <a:prstGeom xmlns:a="http://schemas.openxmlformats.org/drawingml/2006/main" prst="rect">
             <a:avLst/>
@@ -9599,25 +9599,25 @@
                 <a:spcPct val="108000"/>
               </a:lnSpc>
               <a:buNone/>
-              <a:defRPr sz="2325" b="1">
-                <a:solidFill>
-                  <a:srgbClr val="0A0A0A"/>
-                </a:solidFill>
-                <a:latin typeface="Apple SD Gothic Neo"/>
-                <a:ea typeface="Apple SD Gothic Neo"/>
-                <a:cs typeface="Apple SD Gothic Neo"/>
-              </a:defRPr>
-            </a:pPr>
-            <a:r>
-              <a:rPr sz="2325" b="1">
-                <a:solidFill>
-                  <a:srgbClr val="0A0A0A"/>
-                </a:solidFill>
-                <a:latin typeface="Apple SD Gothic Neo"/>
-                <a:ea typeface="Apple SD Gothic Neo"/>
-                <a:cs typeface="Apple SD Gothic Neo"/>
-              </a:rPr>
-              <a:t>캠페인 이용료 + 경품·후속 주문 수수료</a:t>
+              <a:defRPr sz="1500" b="0">
+                <a:solidFill>
+                  <a:srgbClr val="111827"/>
+                </a:solidFill>
+                <a:latin typeface="Apple SD Gothic Neo"/>
+                <a:ea typeface="Apple SD Gothic Neo"/>
+                <a:cs typeface="Apple SD Gothic Neo"/>
+              </a:defRPr>
+            </a:pPr>
+            <a:r>
+              <a:rPr sz="1500" b="0">
+                <a:solidFill>
+                  <a:srgbClr val="111827"/>
+                </a:solidFill>
+                <a:latin typeface="Apple SD Gothic Neo"/>
+                <a:ea typeface="Apple SD Gothic Neo"/>
+                <a:cs typeface="Apple SD Gothic Neo"/>
+              </a:rPr>
+              <a:t>• 글로벌 팬 참여를 국경 없는 구매 여정으로 전환</a:t>
             </a:r>
           </a:p>
         </p:txBody>
@@ -9638,8 +9638,8 @@
         </p:nvSpPr>
         <p:spPr>
           <a:xfrm xmlns:a="http://schemas.openxmlformats.org/drawingml/2006/main">
-            <a:off x="552450" y="4857750"/>
-            <a:ext cx="6858000" cy="361950"/>
+            <a:off x="552450" y="4629150"/>
+            <a:ext cx="5143500" cy="723900"/>
           </a:xfrm>
           <a:prstGeom xmlns:a="http://schemas.openxmlformats.org/drawingml/2006/main" prst="rect">
             <a:avLst/>
@@ -9663,7 +9663,7 @@
               <a:buNone/>
               <a:defRPr sz="1500" b="0">
                 <a:solidFill>
-                  <a:srgbClr val="6F7680"/>
+                  <a:srgbClr val="111827"/>
                 </a:solidFill>
                 <a:latin typeface="Apple SD Gothic Neo"/>
                 <a:ea typeface="Apple SD Gothic Neo"/>
@@ -9673,13 +9673,40 @@
             <a:r>
               <a:rPr sz="1500" b="0">
                 <a:solidFill>
-                  <a:srgbClr val="6F7680"/>
-                </a:solidFill>
-                <a:latin typeface="Apple SD Gothic Neo"/>
-                <a:ea typeface="Apple SD Gothic Neo"/>
-                <a:cs typeface="Apple SD Gothic Neo"/>
-              </a:rPr>
-              <a:t>K-CON · 게임 출시 · 팬미팅 · 스포츠 라이브</a:t>
+                  <a:srgbClr val="111827"/>
+                </a:solidFill>
+                <a:latin typeface="Apple SD Gothic Neo"/>
+                <a:ea typeface="Apple SD Gothic Neo"/>
+                <a:cs typeface="Apple SD Gothic Neo"/>
+              </a:rPr>
+              <a:t>• K-CON·게임 출시·팬미팅·스포츠 라이브로 확장</a:t>
+            </a:r>
+          </a:p>
+          <a:p xmlns:a="http://schemas.openxmlformats.org/drawingml/2006/main">
+            <a:pPr algn="l">
+              <a:lnSpc>
+                <a:spcPct val="108000"/>
+              </a:lnSpc>
+              <a:buNone/>
+              <a:defRPr sz="1500" b="0">
+                <a:solidFill>
+                  <a:srgbClr val="111827"/>
+                </a:solidFill>
+                <a:latin typeface="Apple SD Gothic Neo"/>
+                <a:ea typeface="Apple SD Gothic Neo"/>
+                <a:cs typeface="Apple SD Gothic Neo"/>
+              </a:defRPr>
+            </a:pPr>
+            <a:r>
+              <a:rPr sz="1500" b="0">
+                <a:solidFill>
+                  <a:srgbClr val="111827"/>
+                </a:solidFill>
+                <a:latin typeface="Apple SD Gothic Neo"/>
+                <a:ea typeface="Apple SD Gothic Neo"/>
+                <a:cs typeface="Apple SD Gothic Neo"/>
+              </a:rPr>
+              <a:t>• 참여·국가·상품 데이터를 재구매 자산으로 축적</a:t>
             </a:r>
           </a:p>
         </p:txBody>
@@ -9700,7 +9727,7 @@
         </p:nvSpPr>
         <p:spPr>
           <a:xfrm xmlns:a="http://schemas.openxmlformats.org/drawingml/2006/main">
-            <a:off x="7810500" y="3867150"/>
+            <a:off x="6096000" y="3867150"/>
             <a:ext cx="0" cy="1524000"/>
           </a:xfrm>
           <a:prstGeom xmlns:a="http://schemas.openxmlformats.org/drawingml/2006/main" prst="line">
@@ -9731,8 +9758,8 @@
         </p:nvSpPr>
         <p:spPr>
           <a:xfrm xmlns:a="http://schemas.openxmlformats.org/drawingml/2006/main">
-            <a:off x="8248650" y="3848100"/>
-            <a:ext cx="1714500" cy="285750"/>
+            <a:off x="6534150" y="3848100"/>
+            <a:ext cx="2857500" cy="285750"/>
           </a:xfrm>
           <a:prstGeom xmlns:a="http://schemas.openxmlformats.org/drawingml/2006/main" prst="rect">
             <a:avLst/>
@@ -9772,7 +9799,7 @@
                 <a:ea typeface="Apple SD Gothic Neo"/>
                 <a:cs typeface="Apple SD Gothic Neo"/>
               </a:rPr>
-              <a:t>AI 추천 → 재구매</a:t>
+              <a:t>수익 창출 기대효과</a:t>
             </a:r>
           </a:p>
         </p:txBody>
@@ -9793,8 +9820,8 @@
         </p:nvSpPr>
         <p:spPr>
           <a:xfrm xmlns:a="http://schemas.openxmlformats.org/drawingml/2006/main">
-            <a:off x="8248650" y="4248150"/>
-            <a:ext cx="2857500" cy="1047750"/>
+            <a:off x="6534150" y="4248150"/>
+            <a:ext cx="4762500" cy="1104900"/>
           </a:xfrm>
           <a:prstGeom xmlns:a="http://schemas.openxmlformats.org/drawingml/2006/main" prst="rect">
             <a:avLst/>
@@ -9816,25 +9843,25 @@
                 <a:spcPct val="118000"/>
               </a:lnSpc>
               <a:buNone/>
-              <a:defRPr sz="1725" b="1">
-                <a:solidFill>
-                  <a:srgbClr val="0A0A0A"/>
-                </a:solidFill>
-                <a:latin typeface="Apple SD Gothic Neo"/>
-                <a:ea typeface="Apple SD Gothic Neo"/>
-                <a:cs typeface="Apple SD Gothic Neo"/>
-              </a:defRPr>
-            </a:pPr>
-            <a:r>
-              <a:rPr sz="1725" b="1">
-                <a:solidFill>
-                  <a:srgbClr val="0A0A0A"/>
-                </a:solidFill>
-                <a:latin typeface="Apple SD Gothic Neo"/>
-                <a:ea typeface="Apple SD Gothic Neo"/>
-                <a:cs typeface="Apple SD Gothic Neo"/>
-              </a:rPr>
-              <a:t>행동·취향 데이터 분석</a:t>
+              <a:defRPr sz="1500" b="1">
+                <a:solidFill>
+                  <a:srgbClr val="111827"/>
+                </a:solidFill>
+                <a:latin typeface="Apple SD Gothic Neo"/>
+                <a:ea typeface="Apple SD Gothic Neo"/>
+                <a:cs typeface="Apple SD Gothic Neo"/>
+              </a:defRPr>
+            </a:pPr>
+            <a:r>
+              <a:rPr sz="1500" b="1">
+                <a:solidFill>
+                  <a:srgbClr val="111827"/>
+                </a:solidFill>
+                <a:latin typeface="Apple SD Gothic Neo"/>
+                <a:ea typeface="Apple SD Gothic Neo"/>
+                <a:cs typeface="Apple SD Gothic Neo"/>
+              </a:rPr>
+              <a:t>• 캠페인 운영 이용료</a:t>
             </a:r>
           </a:p>
           <a:p xmlns:a="http://schemas.openxmlformats.org/drawingml/2006/main">
@@ -9843,25 +9870,25 @@
                 <a:spcPct val="118000"/>
               </a:lnSpc>
               <a:buNone/>
-              <a:defRPr sz="1725" b="1">
-                <a:solidFill>
-                  <a:srgbClr val="0A0A0A"/>
-                </a:solidFill>
-                <a:latin typeface="Apple SD Gothic Neo"/>
-                <a:ea typeface="Apple SD Gothic Neo"/>
-                <a:cs typeface="Apple SD Gothic Neo"/>
-              </a:defRPr>
-            </a:pPr>
-            <a:r>
-              <a:rPr sz="1725" b="1">
-                <a:solidFill>
-                  <a:srgbClr val="0A0A0A"/>
-                </a:solidFill>
-                <a:latin typeface="Apple SD Gothic Neo"/>
-                <a:ea typeface="Apple SD Gothic Neo"/>
-                <a:cs typeface="Apple SD Gothic Neo"/>
-              </a:rPr>
-              <a:t>맞춤 상품 Top 3 추천</a:t>
+              <a:defRPr sz="1500" b="1">
+                <a:solidFill>
+                  <a:srgbClr val="111827"/>
+                </a:solidFill>
+                <a:latin typeface="Apple SD Gothic Neo"/>
+                <a:ea typeface="Apple SD Gothic Neo"/>
+                <a:cs typeface="Apple SD Gothic Neo"/>
+              </a:defRPr>
+            </a:pPr>
+            <a:r>
+              <a:rPr sz="1500" b="1">
+                <a:solidFill>
+                  <a:srgbClr val="111827"/>
+                </a:solidFill>
+                <a:latin typeface="Apple SD Gothic Neo"/>
+                <a:ea typeface="Apple SD Gothic Neo"/>
+                <a:cs typeface="Apple SD Gothic Neo"/>
+              </a:rPr>
+              <a:t>• 경품·후속 주문 수수료</a:t>
             </a:r>
           </a:p>
           <a:p xmlns:a="http://schemas.openxmlformats.org/drawingml/2006/main">
@@ -9870,25 +9897,25 @@
                 <a:spcPct val="118000"/>
               </a:lnSpc>
               <a:buNone/>
-              <a:defRPr sz="1725" b="1">
-                <a:solidFill>
-                  <a:srgbClr val="0A0A0A"/>
-                </a:solidFill>
-                <a:latin typeface="Apple SD Gothic Neo"/>
-                <a:ea typeface="Apple SD Gothic Neo"/>
-                <a:cs typeface="Apple SD Gothic Neo"/>
-              </a:defRPr>
-            </a:pPr>
-            <a:r>
-              <a:rPr sz="1725" b="1">
-                <a:solidFill>
-                  <a:srgbClr val="0A0A0A"/>
-                </a:solidFill>
-                <a:latin typeface="Apple SD Gothic Neo"/>
-                <a:ea typeface="Apple SD Gothic Neo"/>
-                <a:cs typeface="Apple SD Gothic Neo"/>
-              </a:rPr>
-              <a:t>후속 구매 → 반복 주문</a:t>
+              <a:defRPr sz="1500" b="1">
+                <a:solidFill>
+                  <a:srgbClr val="111827"/>
+                </a:solidFill>
+                <a:latin typeface="Apple SD Gothic Neo"/>
+                <a:ea typeface="Apple SD Gothic Neo"/>
+                <a:cs typeface="Apple SD Gothic Neo"/>
+              </a:defRPr>
+            </a:pPr>
+            <a:r>
+              <a:rPr sz="1500" b="1">
+                <a:solidFill>
+                  <a:srgbClr val="111827"/>
+                </a:solidFill>
+                <a:latin typeface="Apple SD Gothic Neo"/>
+                <a:ea typeface="Apple SD Gothic Neo"/>
+                <a:cs typeface="Apple SD Gothic Neo"/>
+              </a:rPr>
+              <a:t>• AI 추천으로 반복 구매·고객가치(LTV) 확대</a:t>
             </a:r>
           </a:p>
         </p:txBody>
@@ -16099,7 +16126,7 @@
           <p:cNvPr id="29" name="stage-5-title">
             <a:extLst xmlns:a="http://schemas.openxmlformats.org/drawingml/2006/main">
               <a:ext uri="{FF2B5EF4-FFF2-40B4-BE49-F238E27FC236}">
-                <a16:creationId xmlns:a16="http://schemas.microsoft.com/office/drawing/2014/main" id="{6E283268-E0B9-4786-90C6-A164BE8621FF}"/>
+                <a16:creationId xmlns:a16="http://schemas.microsoft.com/office/drawing/2014/main" id="{3706986F-5AF4-4509-9EA7-7DBA4BBABE6A}"/>
               </a:ext>
             </a:extLst>
           </p:cNvPr>
@@ -16155,7 +16182,7 @@
           <p:cNvPr id="30" name="stage-5-subtitle">
             <a:extLst xmlns:a="http://schemas.openxmlformats.org/drawingml/2006/main">
               <a:ext uri="{FF2B5EF4-FFF2-40B4-BE49-F238E27FC236}">
-                <a16:creationId xmlns:a16="http://schemas.microsoft.com/office/drawing/2014/main" id="{B23BDDB4-5CAA-4A76-AA37-876271FD16EB}"/>
+                <a16:creationId xmlns:a16="http://schemas.microsoft.com/office/drawing/2014/main" id="{17736E46-9761-42C4-A345-97D7E7229F06}"/>
               </a:ext>
             </a:extLst>
           </p:cNvPr>
@@ -16211,7 +16238,7 @@
           <p:cNvPr id="31" name="stage-5-page">
             <a:extLst xmlns:a="http://schemas.openxmlformats.org/drawingml/2006/main">
               <a:ext uri="{FF2B5EF4-FFF2-40B4-BE49-F238E27FC236}">
-                <a16:creationId xmlns:a16="http://schemas.microsoft.com/office/drawing/2014/main" id="{9A16BF56-5F9A-4EC2-BEDD-FE53743D77F5}"/>
+                <a16:creationId xmlns:a16="http://schemas.microsoft.com/office/drawing/2014/main" id="{04014B17-7D0B-4BEC-BBE0-53E5B0C043B0}"/>
               </a:ext>
             </a:extLst>
           </p:cNvPr>
@@ -16267,7 +16294,7 @@
           <p:cNvPr id="32" name="event-start-admin-frame">
             <a:extLst xmlns:a="http://schemas.openxmlformats.org/drawingml/2006/main">
               <a:ext uri="{FF2B5EF4-FFF2-40B4-BE49-F238E27FC236}">
-                <a16:creationId xmlns:a16="http://schemas.microsoft.com/office/drawing/2014/main" id="{92BCF4ED-F017-4EAE-9D03-72EE400A3B8D}"/>
+                <a16:creationId xmlns:a16="http://schemas.microsoft.com/office/drawing/2014/main" id="{8F0BE628-EEDF-42CE-9450-8EBE126DE772}"/>
               </a:ext>
             </a:extLst>
           </p:cNvPr>
@@ -16306,7 +16333,7 @@
           <p:nvPr/>
         </p:nvPicPr>
         <p:blipFill>
-          <a:blip xmlns:r="http://schemas.openxmlformats.org/officeDocument/2006/relationships" xmlns:a="http://schemas.openxmlformats.org/drawingml/2006/main" r:embed="Ra66b0647e4384d73"/>
+          <a:blip xmlns:r="http://schemas.openxmlformats.org/officeDocument/2006/relationships" xmlns:a="http://schemas.openxmlformats.org/drawingml/2006/main" r:embed="R442ac3625bdb49b9"/>
           <a:stretch xmlns:a="http://schemas.openxmlformats.org/drawingml/2006/main"/>
         </p:blipFill>
         <p:spPr>
@@ -16324,7 +16351,7 @@
           <p:cNvPr id="34" name="event-start-caption">
             <a:extLst xmlns:a="http://schemas.openxmlformats.org/drawingml/2006/main">
               <a:ext uri="{FF2B5EF4-FFF2-40B4-BE49-F238E27FC236}">
-                <a16:creationId xmlns:a16="http://schemas.microsoft.com/office/drawing/2014/main" id="{2DE58E68-88DC-424C-83FC-7434E72D2A80}"/>
+                <a16:creationId xmlns:a16="http://schemas.microsoft.com/office/drawing/2014/main" id="{166F8B76-6CCF-4F0A-BDA2-FB92C48E5A44}"/>
               </a:ext>
             </a:extLst>
           </p:cNvPr>
@@ -17885,7 +17912,7 @@
           <p:cNvPr id="29" name="stage-6-title">
             <a:extLst xmlns:a="http://schemas.openxmlformats.org/drawingml/2006/main">
               <a:ext uri="{FF2B5EF4-FFF2-40B4-BE49-F238E27FC236}">
-                <a16:creationId xmlns:a16="http://schemas.microsoft.com/office/drawing/2014/main" id="{756776CD-BD6D-47D8-93AC-2BEA217A8611}"/>
+                <a16:creationId xmlns:a16="http://schemas.microsoft.com/office/drawing/2014/main" id="{990F4299-5972-4868-8D97-CF6EE42264BC}"/>
               </a:ext>
             </a:extLst>
           </p:cNvPr>
@@ -17941,7 +17968,7 @@
           <p:cNvPr id="30" name="stage-6-subtitle">
             <a:extLst xmlns:a="http://schemas.openxmlformats.org/drawingml/2006/main">
               <a:ext uri="{FF2B5EF4-FFF2-40B4-BE49-F238E27FC236}">
-                <a16:creationId xmlns:a16="http://schemas.microsoft.com/office/drawing/2014/main" id="{39A9AB45-9305-483D-B5D2-7499003B493B}"/>
+                <a16:creationId xmlns:a16="http://schemas.microsoft.com/office/drawing/2014/main" id="{2D943627-1129-477E-A637-A8AEA7322B24}"/>
               </a:ext>
             </a:extLst>
           </p:cNvPr>
@@ -17997,7 +18024,7 @@
           <p:cNvPr id="31" name="stage-6-page">
             <a:extLst xmlns:a="http://schemas.openxmlformats.org/drawingml/2006/main">
               <a:ext uri="{FF2B5EF4-FFF2-40B4-BE49-F238E27FC236}">
-                <a16:creationId xmlns:a16="http://schemas.microsoft.com/office/drawing/2014/main" id="{08402D60-4B8A-41D5-9D58-EB3731736734}"/>
+                <a16:creationId xmlns:a16="http://schemas.microsoft.com/office/drawing/2014/main" id="{8F633D4E-B258-41D7-8D80-A66D833F12F7}"/>
               </a:ext>
             </a:extLst>
           </p:cNvPr>
@@ -18053,7 +18080,7 @@
           <p:cNvPr id="32" name="registration-overlay-frame">
             <a:extLst xmlns:a="http://schemas.openxmlformats.org/drawingml/2006/main">
               <a:ext uri="{FF2B5EF4-FFF2-40B4-BE49-F238E27FC236}">
-                <a16:creationId xmlns:a16="http://schemas.microsoft.com/office/drawing/2014/main" id="{1C1C336C-06C5-4C88-B430-68D9BC7A3DD8}"/>
+                <a16:creationId xmlns:a16="http://schemas.microsoft.com/office/drawing/2014/main" id="{5542C100-C5A9-4298-AFB9-44689B6EB9A5}"/>
               </a:ext>
             </a:extLst>
           </p:cNvPr>
@@ -18092,7 +18119,7 @@
           <p:nvPr/>
         </p:nvPicPr>
         <p:blipFill>
-          <a:blip xmlns:r="http://schemas.openxmlformats.org/officeDocument/2006/relationships" xmlns:a="http://schemas.openxmlformats.org/drawingml/2006/main" r:embed="Rcc536a3df3ef49c1"/>
+          <a:blip xmlns:r="http://schemas.openxmlformats.org/officeDocument/2006/relationships" xmlns:a="http://schemas.openxmlformats.org/drawingml/2006/main" r:embed="R8ab58301b3834363"/>
           <a:stretch xmlns:a="http://schemas.openxmlformats.org/drawingml/2006/main"/>
         </p:blipFill>
         <p:spPr>
@@ -19615,7 +19642,7 @@
           <p:cNvPr id="29" name="stage-7-title">
             <a:extLst xmlns:a="http://schemas.openxmlformats.org/drawingml/2006/main">
               <a:ext uri="{FF2B5EF4-FFF2-40B4-BE49-F238E27FC236}">
-                <a16:creationId xmlns:a16="http://schemas.microsoft.com/office/drawing/2014/main" id="{E3340EFA-A188-464E-87DA-F8AA0CD5D9A0}"/>
+                <a16:creationId xmlns:a16="http://schemas.microsoft.com/office/drawing/2014/main" id="{1A2E5B16-FCA9-4875-B147-CBFE19C04D5E}"/>
               </a:ext>
             </a:extLst>
           </p:cNvPr>
@@ -19671,7 +19698,7 @@
           <p:cNvPr id="30" name="stage-7-subtitle">
             <a:extLst xmlns:a="http://schemas.openxmlformats.org/drawingml/2006/main">
               <a:ext uri="{FF2B5EF4-FFF2-40B4-BE49-F238E27FC236}">
-                <a16:creationId xmlns:a16="http://schemas.microsoft.com/office/drawing/2014/main" id="{2D332293-CB30-4215-B357-9A2ECEB7DF26}"/>
+                <a16:creationId xmlns:a16="http://schemas.microsoft.com/office/drawing/2014/main" id="{550CA3ED-D2AF-4237-9F26-4F05B74425A0}"/>
               </a:ext>
             </a:extLst>
           </p:cNvPr>
@@ -19727,7 +19754,7 @@
           <p:cNvPr id="31" name="stage-7-page">
             <a:extLst xmlns:a="http://schemas.openxmlformats.org/drawingml/2006/main">
               <a:ext uri="{FF2B5EF4-FFF2-40B4-BE49-F238E27FC236}">
-                <a16:creationId xmlns:a16="http://schemas.microsoft.com/office/drawing/2014/main" id="{C662E23E-258B-42BF-83CF-CC8CFBEBBEEF}"/>
+                <a16:creationId xmlns:a16="http://schemas.microsoft.com/office/drawing/2014/main" id="{7330D4BC-CC98-45E3-BE81-7D57374752C6}"/>
               </a:ext>
             </a:extLst>
           </p:cNvPr>
@@ -19783,7 +19810,7 @@
           <p:cNvPr id="32" name="confirmation-admin-label">
             <a:extLst xmlns:a="http://schemas.openxmlformats.org/drawingml/2006/main">
               <a:ext uri="{FF2B5EF4-FFF2-40B4-BE49-F238E27FC236}">
-                <a16:creationId xmlns:a16="http://schemas.microsoft.com/office/drawing/2014/main" id="{60080329-A26C-419F-BFC0-83DBF1244071}"/>
+                <a16:creationId xmlns:a16="http://schemas.microsoft.com/office/drawing/2014/main" id="{E3B79AC1-070E-496A-84DB-45D429361B46}"/>
               </a:ext>
             </a:extLst>
           </p:cNvPr>
@@ -19839,7 +19866,7 @@
           <p:cNvPr id="33" name="confirmation-mobile-label">
             <a:extLst xmlns:a="http://schemas.openxmlformats.org/drawingml/2006/main">
               <a:ext uri="{FF2B5EF4-FFF2-40B4-BE49-F238E27FC236}">
-                <a16:creationId xmlns:a16="http://schemas.microsoft.com/office/drawing/2014/main" id="{42DBDE37-DBC6-4025-A445-53BF43825738}"/>
+                <a16:creationId xmlns:a16="http://schemas.microsoft.com/office/drawing/2014/main" id="{692D8FBA-ADAE-4DEE-B29B-B5CE9994DC31}"/>
               </a:ext>
             </a:extLst>
           </p:cNvPr>
@@ -19895,7 +19922,7 @@
           <p:cNvPr id="34" name="confirmation-admin-frame">
             <a:extLst xmlns:a="http://schemas.openxmlformats.org/drawingml/2006/main">
               <a:ext uri="{FF2B5EF4-FFF2-40B4-BE49-F238E27FC236}">
-                <a16:creationId xmlns:a16="http://schemas.microsoft.com/office/drawing/2014/main" id="{49CA6908-1799-4CCA-BCAB-8BD79FAD9EA7}"/>
+                <a16:creationId xmlns:a16="http://schemas.microsoft.com/office/drawing/2014/main" id="{E64B9897-DF01-4EDA-B7A1-E3B189612460}"/>
               </a:ext>
             </a:extLst>
           </p:cNvPr>
@@ -19934,7 +19961,7 @@
           <p:nvPr/>
         </p:nvPicPr>
         <p:blipFill>
-          <a:blip xmlns:r="http://schemas.openxmlformats.org/officeDocument/2006/relationships" xmlns:a="http://schemas.openxmlformats.org/drawingml/2006/main" r:embed="R5afe3b80dcff4a38"/>
+          <a:blip xmlns:r="http://schemas.openxmlformats.org/officeDocument/2006/relationships" xmlns:a="http://schemas.openxmlformats.org/drawingml/2006/main" r:embed="R4bab452a7c3d49ed"/>
           <a:stretch xmlns:a="http://schemas.openxmlformats.org/drawingml/2006/main"/>
         </p:blipFill>
         <p:spPr>
@@ -19952,7 +19979,7 @@
           <p:cNvPr id="36" name="confirmation-mobile-frame">
             <a:extLst xmlns:a="http://schemas.openxmlformats.org/drawingml/2006/main">
               <a:ext uri="{FF2B5EF4-FFF2-40B4-BE49-F238E27FC236}">
-                <a16:creationId xmlns:a16="http://schemas.microsoft.com/office/drawing/2014/main" id="{27AF112B-E8A6-412F-B7D4-3B9EE0B83284}"/>
+                <a16:creationId xmlns:a16="http://schemas.microsoft.com/office/drawing/2014/main" id="{7520A7F3-E85F-4DCE-8507-639A51B0FC7D}"/>
               </a:ext>
             </a:extLst>
           </p:cNvPr>
@@ -19991,7 +20018,7 @@
           <p:nvPr/>
         </p:nvPicPr>
         <p:blipFill>
-          <a:blip xmlns:r="http://schemas.openxmlformats.org/officeDocument/2006/relationships" xmlns:a="http://schemas.openxmlformats.org/drawingml/2006/main" r:embed="R2b02f001478945ae"/>
+          <a:blip xmlns:r="http://schemas.openxmlformats.org/officeDocument/2006/relationships" xmlns:a="http://schemas.openxmlformats.org/drawingml/2006/main" r:embed="R2f66eb95205742a5"/>
           <a:stretch xmlns:a="http://schemas.openxmlformats.org/drawingml/2006/main"/>
         </p:blipFill>
         <p:spPr>
@@ -20009,7 +20036,7 @@
           <p:cNvPr id="38" name="confirmation-caption">
             <a:extLst xmlns:a="http://schemas.openxmlformats.org/drawingml/2006/main">
               <a:ext uri="{FF2B5EF4-FFF2-40B4-BE49-F238E27FC236}">
-                <a16:creationId xmlns:a16="http://schemas.microsoft.com/office/drawing/2014/main" id="{D3BBF08E-80BD-4D7D-A3DD-2978FA04E9B9}"/>
+                <a16:creationId xmlns:a16="http://schemas.microsoft.com/office/drawing/2014/main" id="{5DD18A26-E187-4FE0-B4C8-9BE93F4C661A}"/>
               </a:ext>
             </a:extLst>
           </p:cNvPr>
@@ -21570,7 +21597,7 @@
           <p:cNvPr id="29" name="stage-8-title">
             <a:extLst xmlns:a="http://schemas.openxmlformats.org/drawingml/2006/main">
               <a:ext uri="{FF2B5EF4-FFF2-40B4-BE49-F238E27FC236}">
-                <a16:creationId xmlns:a16="http://schemas.microsoft.com/office/drawing/2014/main" id="{74974DEA-FC2B-46D6-B807-F26B935BE1A0}"/>
+                <a16:creationId xmlns:a16="http://schemas.microsoft.com/office/drawing/2014/main" id="{2A84CD39-CBDC-48AA-A65C-371D3E51B55D}"/>
               </a:ext>
             </a:extLst>
           </p:cNvPr>
@@ -21626,7 +21653,7 @@
           <p:cNvPr id="30" name="stage-8-subtitle">
             <a:extLst xmlns:a="http://schemas.openxmlformats.org/drawingml/2006/main">
               <a:ext uri="{FF2B5EF4-FFF2-40B4-BE49-F238E27FC236}">
-                <a16:creationId xmlns:a16="http://schemas.microsoft.com/office/drawing/2014/main" id="{652B7E9C-FA6A-4440-B76D-265A0279056D}"/>
+                <a16:creationId xmlns:a16="http://schemas.microsoft.com/office/drawing/2014/main" id="{DA237C6B-0CDE-4761-8951-AFB90DFD6E3C}"/>
               </a:ext>
             </a:extLst>
           </p:cNvPr>
@@ -21682,7 +21709,7 @@
           <p:cNvPr id="31" name="stage-8-page">
             <a:extLst xmlns:a="http://schemas.openxmlformats.org/drawingml/2006/main">
               <a:ext uri="{FF2B5EF4-FFF2-40B4-BE49-F238E27FC236}">
-                <a16:creationId xmlns:a16="http://schemas.microsoft.com/office/drawing/2014/main" id="{2597FCA2-642A-4E33-BB75-994D7494AD7D}"/>
+                <a16:creationId xmlns:a16="http://schemas.microsoft.com/office/drawing/2014/main" id="{30FF151D-18F3-4299-BD6A-8F25AD24CC5F}"/>
               </a:ext>
             </a:extLst>
           </p:cNvPr>
@@ -21738,7 +21765,7 @@
           <p:cNvPr id="32" name="raffle-overlay-label">
             <a:extLst xmlns:a="http://schemas.openxmlformats.org/drawingml/2006/main">
               <a:ext uri="{FF2B5EF4-FFF2-40B4-BE49-F238E27FC236}">
-                <a16:creationId xmlns:a16="http://schemas.microsoft.com/office/drawing/2014/main" id="{2D10DE0C-1D40-488C-A111-D2A1AE4CB4BE}"/>
+                <a16:creationId xmlns:a16="http://schemas.microsoft.com/office/drawing/2014/main" id="{10605487-8C75-4256-9DB0-26F4FEA066A5}"/>
               </a:ext>
             </a:extLst>
           </p:cNvPr>
@@ -21794,7 +21821,7 @@
           <p:cNvPr id="33" name="raffle-admin-label">
             <a:extLst xmlns:a="http://schemas.openxmlformats.org/drawingml/2006/main">
               <a:ext uri="{FF2B5EF4-FFF2-40B4-BE49-F238E27FC236}">
-                <a16:creationId xmlns:a16="http://schemas.microsoft.com/office/drawing/2014/main" id="{A47ACCA5-E180-4128-8D63-472426E72362}"/>
+                <a16:creationId xmlns:a16="http://schemas.microsoft.com/office/drawing/2014/main" id="{6E05A02C-0044-4038-BB11-71481A1F32C5}"/>
               </a:ext>
             </a:extLst>
           </p:cNvPr>
@@ -21850,7 +21877,7 @@
           <p:cNvPr id="34" name="raffle-overlay-frame">
             <a:extLst xmlns:a="http://schemas.openxmlformats.org/drawingml/2006/main">
               <a:ext uri="{FF2B5EF4-FFF2-40B4-BE49-F238E27FC236}">
-                <a16:creationId xmlns:a16="http://schemas.microsoft.com/office/drawing/2014/main" id="{A1FC218F-C67D-44ED-AD58-270F8407F684}"/>
+                <a16:creationId xmlns:a16="http://schemas.microsoft.com/office/drawing/2014/main" id="{88DA0917-9384-4359-B61F-B83A057365D2}"/>
               </a:ext>
             </a:extLst>
           </p:cNvPr>
@@ -21889,7 +21916,7 @@
           <p:nvPr/>
         </p:nvPicPr>
         <p:blipFill>
-          <a:blip xmlns:r="http://schemas.openxmlformats.org/officeDocument/2006/relationships" xmlns:a="http://schemas.openxmlformats.org/drawingml/2006/main" r:embed="Rc377961abf7549e4"/>
+          <a:blip xmlns:r="http://schemas.openxmlformats.org/officeDocument/2006/relationships" xmlns:a="http://schemas.openxmlformats.org/drawingml/2006/main" r:embed="Rb3befb3787fa4ea7"/>
           <a:stretch xmlns:a="http://schemas.openxmlformats.org/drawingml/2006/main"/>
         </p:blipFill>
         <p:spPr>
@@ -21907,7 +21934,7 @@
           <p:cNvPr id="36" name="raffle-admin-frame">
             <a:extLst xmlns:a="http://schemas.openxmlformats.org/drawingml/2006/main">
               <a:ext uri="{FF2B5EF4-FFF2-40B4-BE49-F238E27FC236}">
-                <a16:creationId xmlns:a16="http://schemas.microsoft.com/office/drawing/2014/main" id="{CA365C78-0488-485A-927F-E38DB59FC05C}"/>
+                <a16:creationId xmlns:a16="http://schemas.microsoft.com/office/drawing/2014/main" id="{1429917D-85EC-4521-86D3-BA4ABC4272DF}"/>
               </a:ext>
             </a:extLst>
           </p:cNvPr>
@@ -21946,7 +21973,7 @@
           <p:nvPr/>
         </p:nvPicPr>
         <p:blipFill>
-          <a:blip xmlns:r="http://schemas.openxmlformats.org/officeDocument/2006/relationships" xmlns:a="http://schemas.openxmlformats.org/drawingml/2006/main" r:embed="R4bebb8091da6435a"/>
+          <a:blip xmlns:r="http://schemas.openxmlformats.org/officeDocument/2006/relationships" xmlns:a="http://schemas.openxmlformats.org/drawingml/2006/main" r:embed="R51d9264e70bc47e1"/>
           <a:stretch xmlns:a="http://schemas.openxmlformats.org/drawingml/2006/main"/>
         </p:blipFill>
         <p:spPr>
@@ -21964,7 +21991,7 @@
           <p:cNvPr id="38" name="raffle-mobile-label">
             <a:extLst xmlns:a="http://schemas.openxmlformats.org/drawingml/2006/main">
               <a:ext uri="{FF2B5EF4-FFF2-40B4-BE49-F238E27FC236}">
-                <a16:creationId xmlns:a16="http://schemas.microsoft.com/office/drawing/2014/main" id="{D30F4F38-6050-4B1A-BCCB-A018375C667E}"/>
+                <a16:creationId xmlns:a16="http://schemas.microsoft.com/office/drawing/2014/main" id="{91883A4B-35B8-4145-847E-DADE37527F3B}"/>
               </a:ext>
             </a:extLst>
           </p:cNvPr>
@@ -22020,7 +22047,7 @@
           <p:cNvPr id="39" name="raffle-mobile-frame">
             <a:extLst xmlns:a="http://schemas.openxmlformats.org/drawingml/2006/main">
               <a:ext uri="{FF2B5EF4-FFF2-40B4-BE49-F238E27FC236}">
-                <a16:creationId xmlns:a16="http://schemas.microsoft.com/office/drawing/2014/main" id="{3C2DD919-2FC7-43B4-84A0-98D3959EE2BC}"/>
+                <a16:creationId xmlns:a16="http://schemas.microsoft.com/office/drawing/2014/main" id="{D6E5FB68-95A7-4482-BB36-1C9408171754}"/>
               </a:ext>
             </a:extLst>
           </p:cNvPr>
@@ -22059,7 +22086,7 @@
           <p:nvPr/>
         </p:nvPicPr>
         <p:blipFill>
-          <a:blip xmlns:r="http://schemas.openxmlformats.org/officeDocument/2006/relationships" xmlns:a="http://schemas.openxmlformats.org/drawingml/2006/main" r:embed="Rae1c95ac315840f7"/>
+          <a:blip xmlns:r="http://schemas.openxmlformats.org/officeDocument/2006/relationships" xmlns:a="http://schemas.openxmlformats.org/drawingml/2006/main" r:embed="R5abff9914128442e"/>
           <a:stretch xmlns:a="http://schemas.openxmlformats.org/drawingml/2006/main"/>
         </p:blipFill>
         <p:spPr>
@@ -23582,7 +23609,7 @@
           <p:cNvPr id="29" name="stage-9-title">
             <a:extLst xmlns:a="http://schemas.openxmlformats.org/drawingml/2006/main">
               <a:ext uri="{FF2B5EF4-FFF2-40B4-BE49-F238E27FC236}">
-                <a16:creationId xmlns:a16="http://schemas.microsoft.com/office/drawing/2014/main" id="{9C67947C-1D00-4F05-A4E8-17F4440E85CF}"/>
+                <a16:creationId xmlns:a16="http://schemas.microsoft.com/office/drawing/2014/main" id="{67214DC8-4794-4D1D-948D-F5B6FC89A72E}"/>
               </a:ext>
             </a:extLst>
           </p:cNvPr>
@@ -23638,7 +23665,7 @@
           <p:cNvPr id="30" name="stage-9-subtitle">
             <a:extLst xmlns:a="http://schemas.openxmlformats.org/drawingml/2006/main">
               <a:ext uri="{FF2B5EF4-FFF2-40B4-BE49-F238E27FC236}">
-                <a16:creationId xmlns:a16="http://schemas.microsoft.com/office/drawing/2014/main" id="{4A65A450-65F7-4518-9B63-8447E03991C3}"/>
+                <a16:creationId xmlns:a16="http://schemas.microsoft.com/office/drawing/2014/main" id="{E847C03E-054D-44A7-9B56-3BAC6E2724E9}"/>
               </a:ext>
             </a:extLst>
           </p:cNvPr>
@@ -23694,7 +23721,7 @@
           <p:cNvPr id="31" name="stage-9-page">
             <a:extLst xmlns:a="http://schemas.openxmlformats.org/drawingml/2006/main">
               <a:ext uri="{FF2B5EF4-FFF2-40B4-BE49-F238E27FC236}">
-                <a16:creationId xmlns:a16="http://schemas.microsoft.com/office/drawing/2014/main" id="{2EEC621C-8685-4610-AF5B-D288360E4929}"/>
+                <a16:creationId xmlns:a16="http://schemas.microsoft.com/office/drawing/2014/main" id="{8F63346D-B348-430D-B597-A61223CB7A50}"/>
               </a:ext>
             </a:extLst>
           </p:cNvPr>
@@ -23750,7 +23777,7 @@
           <p:cNvPr id="32" name="gift-button-frame">
             <a:extLst xmlns:a="http://schemas.openxmlformats.org/drawingml/2006/main">
               <a:ext uri="{FF2B5EF4-FFF2-40B4-BE49-F238E27FC236}">
-                <a16:creationId xmlns:a16="http://schemas.microsoft.com/office/drawing/2014/main" id="{3D3D6C75-2E33-4A7F-8BA3-7816A2D67F54}"/>
+                <a16:creationId xmlns:a16="http://schemas.microsoft.com/office/drawing/2014/main" id="{242038B7-AB0F-4521-A321-4AB2E5DDBA0E}"/>
               </a:ext>
             </a:extLst>
           </p:cNvPr>
@@ -23789,7 +23816,7 @@
           <p:nvPr/>
         </p:nvPicPr>
         <p:blipFill>
-          <a:blip xmlns:r="http://schemas.openxmlformats.org/officeDocument/2006/relationships" xmlns:a="http://schemas.openxmlformats.org/drawingml/2006/main" r:embed="R4d119840918e4607"/>
+          <a:blip xmlns:r="http://schemas.openxmlformats.org/officeDocument/2006/relationships" xmlns:a="http://schemas.openxmlformats.org/drawingml/2006/main" r:embed="R2e20486453f0429f"/>
           <a:stretch xmlns:a="http://schemas.openxmlformats.org/drawingml/2006/main"/>
         </p:blipFill>
         <p:spPr>

</xml_diff>